<commit_message>
Ostholsteiner Modellschulen namentlich belegt
Die DISW-Gesamtevaluation ist erreichbar und nennt die Standorte: drei
Einzelschulen in Neustadt, Bad Schwartau und Schoenwalde sowie die
Modellregion Fehmarn mit vier Schulen, darunter Inselschule, Grundschule
Burg und Montessori-Schule. Wichtig fuer das Marktbild: In der
Modellregion Fehmarn wurde je Schule ein eigener Pool eingerichtet, nicht
ein regionsweiter.

Der Zeitstrahl auf Folie 1 nennt die Schulen jetzt beim Namen. Die
Leistungserbringer bleiben offen, der Bericht anonymisiert sie
durchgaengig.

Ausserdem in der Belegdatei festgehalten, dass der ueber ker-leipzig.de
verlinkte Sachstandsbericht vom Jugendhilfeausschuss der Stadt Leipzig
stammt und nicht der gesuchte Bericht der Landesregierung
Schleswig-Holstein ist.

Co-Authored-By: Claude Opus 5 <noreply@anthropic.com>
Claude-Session: https://claude.ai/code/session_01BEmnWqa61oLKbobLRTCy2v
</commit_message>
<xml_diff>
--- a/praesentation2/SKP-Poolreform-Modelle-und-Financial-Model.pptx
+++ b/praesentation2/SKP-Poolreform-Modelle-und-Financial-Model.pptx
@@ -49504,7 +49504,7 @@
                 </a:solidFill>
                 <a:latin typeface="Open Sans"/>
               </a:rPr>
-              <a:t>Ostholstein: 7 Modellschulen in 4 Regionen, wissenschaftlich begleitet vom DISW</a:t>
+              <a:t>Ostholstein: 7 Modellschulen, u. a. Inselschule Fehmarn und Neustädter Bucht. Je Schule ein eigener Pool</a:t>
             </a:r>
           </a:p>
         </p:txBody>
@@ -50545,7 +50545,7 @@
                 </a:solidFill>
                 <a:latin typeface="Open Sans"/>
               </a:rPr>
-              <a:t>Quellen: Landtag SH Drs. 20/3271 (11.06.2025) und Drs. 20/2643(neu) · Kreis Pinneberg, Konzept „Klassenassistenz“ und PM zum Vertrag mit Familienräume · DISW-Gesamtevaluation Ostholstein 20.11.2023 · TED 246925-2024 · awo-sh.de · lebenshilfe-sh.de · Kartengrundlage GADM/deutschlandGeoJSON.</a:t>
+              <a:t>Quellen: Landtag SH Drs. 20/3271 (11.06.2025) und Drs. 20/2643(neu) · Kreis Pinneberg, Konzept „Klassenassistenz“ und PM zum Vertrag mit Familienräume · DISW-Gesamtevaluation Ostholstein 20.11.2023, S. 5 und 21 f. · TED 246925-2024 · awo-sh.de · lebenshilfe-sh.de · Kartengrundlage GADM/deutschlandGeoJSON.</a:t>
             </a:r>
           </a:p>
         </p:txBody>

</xml_diff>